<commit_message>
Fix layout defects found in visual review of the deck
- Every text box now carries an explicit vertical anchor; the library
  defaults to centred, which pushed lists and labels below their intended
  position and caused collisions on slides 7 and 8.
- Slide 6: widen the slice bars so the block fills the width and the
  captions stop running under the prototype card.
- Slide 7: pull the right-hand column in to a proper edge margin.
- Slide 8: darken the left card heading (was below 3:1 on the tint) and
  match the two cards' geometry.
- Slide 9: move the polarity marks clear of the nodes, darken the legend.
- Slide 10: the axis label no longer sits on the axis line.

Co-Authored-By: Claude Opus 5 <noreply@anthropic.com>
Claude-Session: https://claude.ai/code/session_016sP6xZ2wHVCdoUacJamk7a
</commit_message>
<xml_diff>
--- a/slides/what-good-development-looks-like.pptx
+++ b/slides/what-good-development-looks-like.pptx
@@ -2172,7 +2172,7 @@
         </p:nvSpPr>
         <p:spPr>
           <a:xfrm>
-            <a:off x="484632" y="1920240"/>
+            <a:off x="1179576" y="2020824"/>
             <a:ext cx="1463040" cy="256032"/>
           </a:xfrm>
           <a:prstGeom prst="rect">
@@ -2244,7 +2244,7 @@
           <a:ln/>
         </p:spPr>
         <p:txBody>
-          <a:bodyPr wrap="square" lIns="0" tIns="0" rIns="0" bIns="0" rtlCol="0" anchor="ctr"/>
+          <a:bodyPr wrap="square" lIns="0" tIns="0" rIns="0" bIns="0" rtlCol="0" anchor="t"/>
           <a:lstStyle/>
           <a:p>
             <a:pPr algn="ctr" indent="0" marL="0">
@@ -3141,7 +3141,7 @@
           <a:ln/>
         </p:spPr>
         <p:txBody>
-          <a:bodyPr wrap="square" lIns="0" tIns="0" rIns="0" bIns="0" rtlCol="0" anchor="ctr"/>
+          <a:bodyPr wrap="square" lIns="0" tIns="0" rIns="0" bIns="0" rtlCol="0" anchor="t"/>
           <a:lstStyle/>
           <a:p>
             <a:pPr indent="0" marL="0">
@@ -4153,7 +4153,7 @@
           <a:ln/>
         </p:spPr>
         <p:txBody>
-          <a:bodyPr wrap="square" lIns="0" tIns="0" rIns="0" bIns="0" rtlCol="0" anchor="ctr"/>
+          <a:bodyPr wrap="square" lIns="0" tIns="0" rIns="0" bIns="0" rtlCol="0" anchor="t"/>
           <a:lstStyle/>
           <a:p>
             <a:pPr indent="0" marL="0">
@@ -4883,7 +4883,7 @@
           <a:ln/>
         </p:spPr>
         <p:txBody>
-          <a:bodyPr wrap="square" lIns="0" tIns="0" rIns="0" bIns="0" rtlCol="0" anchor="ctr"/>
+          <a:bodyPr wrap="square" lIns="0" tIns="0" rIns="0" bIns="0" rtlCol="0" anchor="t"/>
           <a:lstStyle/>
           <a:p>
             <a:pPr indent="0" marL="0">
@@ -5008,7 +5008,7 @@
           <a:ln/>
         </p:spPr>
         <p:txBody>
-          <a:bodyPr wrap="square" lIns="0" tIns="0" rIns="0" bIns="0" rtlCol="0" anchor="ctr"/>
+          <a:bodyPr wrap="square" lIns="0" tIns="0" rIns="0" bIns="0" rtlCol="0" anchor="t"/>
           <a:lstStyle/>
           <a:p>
             <a:pPr indent="0" marL="0">
@@ -5133,7 +5133,7 @@
           <a:ln/>
         </p:spPr>
         <p:txBody>
-          <a:bodyPr wrap="square" lIns="0" tIns="0" rIns="0" bIns="0" rtlCol="0" anchor="ctr"/>
+          <a:bodyPr wrap="square" lIns="0" tIns="0" rIns="0" bIns="0" rtlCol="0" anchor="t"/>
           <a:lstStyle/>
           <a:p>
             <a:pPr indent="0" marL="0">
@@ -5258,7 +5258,7 @@
           <a:ln/>
         </p:spPr>
         <p:txBody>
-          <a:bodyPr wrap="square" lIns="0" tIns="0" rIns="0" bIns="0" rtlCol="0" anchor="ctr"/>
+          <a:bodyPr wrap="square" lIns="0" tIns="0" rIns="0" bIns="0" rtlCol="0" anchor="t"/>
           <a:lstStyle/>
           <a:p>
             <a:pPr indent="0" marL="0">
@@ -5548,7 +5548,7 @@
         <p:spPr>
           <a:xfrm>
             <a:off x="822960" y="1874520"/>
-            <a:ext cx="3108960" cy="530352"/>
+            <a:ext cx="3657600" cy="530352"/>
           </a:xfrm>
           <a:prstGeom prst="rect">
             <a:avLst/>
@@ -5606,8 +5606,8 @@
         </p:nvSpPr>
         <p:spPr>
           <a:xfrm>
-            <a:off x="4160520" y="1874520"/>
-            <a:ext cx="3657600" cy="530352"/>
+            <a:off x="4773168" y="1874520"/>
+            <a:ext cx="3566160" cy="530352"/>
           </a:xfrm>
           <a:prstGeom prst="rect">
             <a:avLst/>
@@ -5646,7 +5646,7 @@
         <p:spPr>
           <a:xfrm>
             <a:off x="822960" y="2624328"/>
-            <a:ext cx="5120640" cy="530352"/>
+            <a:ext cx="5943600" cy="530352"/>
           </a:xfrm>
           <a:prstGeom prst="rect">
             <a:avLst/>
@@ -5704,8 +5704,8 @@
         </p:nvSpPr>
         <p:spPr>
           <a:xfrm>
-            <a:off x="6172200" y="2624328"/>
-            <a:ext cx="3657600" cy="530352"/>
+            <a:off x="7059168" y="2624328"/>
+            <a:ext cx="3566160" cy="530352"/>
           </a:xfrm>
           <a:prstGeom prst="rect">
             <a:avLst/>
@@ -5744,7 +5744,7 @@
         <p:spPr>
           <a:xfrm>
             <a:off x="822960" y="3374136"/>
-            <a:ext cx="7498080" cy="530352"/>
+            <a:ext cx="8595360" cy="530352"/>
           </a:xfrm>
           <a:prstGeom prst="rect">
             <a:avLst/>
@@ -5802,8 +5802,8 @@
         </p:nvSpPr>
         <p:spPr>
           <a:xfrm>
-            <a:off x="8549640" y="3374136"/>
-            <a:ext cx="3657600" cy="530352"/>
+            <a:off x="9710928" y="3374136"/>
+            <a:ext cx="1673352" cy="530352"/>
           </a:xfrm>
           <a:prstGeom prst="rect">
             <a:avLst/>
@@ -5842,7 +5842,7 @@
         <p:spPr>
           <a:xfrm>
             <a:off x="822960" y="4160520"/>
-            <a:ext cx="7498080" cy="0"/>
+            <a:ext cx="8595360" cy="0"/>
           </a:xfrm>
           <a:prstGeom prst="line">
             <a:avLst/>
@@ -5866,7 +5866,7 @@
         <p:spPr>
           <a:xfrm>
             <a:off x="822960" y="4251960"/>
-            <a:ext cx="7498080" cy="274320"/>
+            <a:ext cx="8595360" cy="274320"/>
           </a:xfrm>
           <a:prstGeom prst="rect">
             <a:avLst/>
@@ -5914,7 +5914,7 @@
           <a:ln/>
         </p:spPr>
         <p:txBody>
-          <a:bodyPr wrap="square" lIns="0" tIns="0" rIns="0" bIns="0" rtlCol="0" anchor="ctr"/>
+          <a:bodyPr wrap="square" lIns="0" tIns="0" rIns="0" bIns="0" rtlCol="0" anchor="t"/>
           <a:lstStyle/>
           <a:p>
             <a:pPr indent="0" marL="0">
@@ -6269,7 +6269,7 @@
           <a:ln/>
         </p:spPr>
         <p:txBody>
-          <a:bodyPr wrap="square" lIns="0" tIns="0" rIns="0" bIns="0" rtlCol="0" anchor="ctr"/>
+          <a:bodyPr wrap="square" lIns="0" tIns="0" rIns="0" bIns="0" rtlCol="0" anchor="t"/>
           <a:lstStyle/>
           <a:p>
             <a:pPr indent="0" marL="0">
@@ -6656,8 +6656,8 @@
         </p:nvSpPr>
         <p:spPr>
           <a:xfrm>
-            <a:off x="4315968" y="2286000"/>
-            <a:ext cx="2377440" cy="256032"/>
+            <a:off x="4160520" y="2286000"/>
+            <a:ext cx="2331720" cy="256032"/>
           </a:xfrm>
           <a:prstGeom prst="rect">
             <a:avLst/>
@@ -6695,8 +6695,8 @@
         </p:nvSpPr>
         <p:spPr>
           <a:xfrm>
-            <a:off x="4315968" y="2615184"/>
-            <a:ext cx="2377440" cy="402336"/>
+            <a:off x="4160520" y="2615184"/>
+            <a:ext cx="2331720" cy="402336"/>
           </a:xfrm>
           <a:prstGeom prst="rect">
             <a:avLst/>
@@ -6737,8 +6737,8 @@
         </p:nvSpPr>
         <p:spPr>
           <a:xfrm>
-            <a:off x="4334256" y="2889504"/>
-            <a:ext cx="2359152" cy="1463040"/>
+            <a:off x="4178808" y="2889504"/>
+            <a:ext cx="2313432" cy="1463040"/>
           </a:xfrm>
           <a:prstGeom prst="rect">
             <a:avLst/>
@@ -6831,8 +6831,8 @@
         </p:nvSpPr>
         <p:spPr>
           <a:xfrm>
-            <a:off x="7059168" y="2286000"/>
-            <a:ext cx="2377440" cy="256032"/>
+            <a:off x="6858000" y="2286000"/>
+            <a:ext cx="2331720" cy="256032"/>
           </a:xfrm>
           <a:prstGeom prst="rect">
             <a:avLst/>
@@ -6870,8 +6870,8 @@
         </p:nvSpPr>
         <p:spPr>
           <a:xfrm>
-            <a:off x="7059168" y="2615184"/>
-            <a:ext cx="2377440" cy="402336"/>
+            <a:off x="6858000" y="2615184"/>
+            <a:ext cx="2331720" cy="402336"/>
           </a:xfrm>
           <a:prstGeom prst="rect">
             <a:avLst/>
@@ -6912,8 +6912,8 @@
         </p:nvSpPr>
         <p:spPr>
           <a:xfrm>
-            <a:off x="7077456" y="2889504"/>
-            <a:ext cx="2359152" cy="1463040"/>
+            <a:off x="6876288" y="2889504"/>
+            <a:ext cx="2313432" cy="1463040"/>
           </a:xfrm>
           <a:prstGeom prst="rect">
             <a:avLst/>
@@ -7030,8 +7030,8 @@
         </p:nvSpPr>
         <p:spPr>
           <a:xfrm>
-            <a:off x="7059168" y="4059936"/>
-            <a:ext cx="2377440" cy="402336"/>
+            <a:off x="6858000" y="4059936"/>
+            <a:ext cx="2331720" cy="402336"/>
           </a:xfrm>
           <a:prstGeom prst="rect">
             <a:avLst/>
@@ -7072,8 +7072,8 @@
         </p:nvSpPr>
         <p:spPr>
           <a:xfrm>
-            <a:off x="7077456" y="4334256"/>
-            <a:ext cx="2359152" cy="1463040"/>
+            <a:off x="6876288" y="4334256"/>
+            <a:ext cx="2313432" cy="1463040"/>
           </a:xfrm>
           <a:prstGeom prst="rect">
             <a:avLst/>
@@ -7190,8 +7190,8 @@
         </p:nvSpPr>
         <p:spPr>
           <a:xfrm>
-            <a:off x="9802368" y="2286000"/>
-            <a:ext cx="1975104" cy="256032"/>
+            <a:off x="9555480" y="2286000"/>
+            <a:ext cx="1920240" cy="256032"/>
           </a:xfrm>
           <a:prstGeom prst="rect">
             <a:avLst/>
@@ -7229,8 +7229,8 @@
         </p:nvSpPr>
         <p:spPr>
           <a:xfrm>
-            <a:off x="9802368" y="2615184"/>
-            <a:ext cx="1975104" cy="402336"/>
+            <a:off x="9555480" y="2615184"/>
+            <a:ext cx="1920240" cy="402336"/>
           </a:xfrm>
           <a:prstGeom prst="rect">
             <a:avLst/>
@@ -7271,8 +7271,8 @@
         </p:nvSpPr>
         <p:spPr>
           <a:xfrm>
-            <a:off x="9820656" y="2889504"/>
-            <a:ext cx="1956816" cy="1463040"/>
+            <a:off x="9573768" y="2889504"/>
+            <a:ext cx="1901952" cy="1463040"/>
           </a:xfrm>
           <a:prstGeom prst="rect">
             <a:avLst/>
@@ -7414,7 +7414,7 @@
         <p:spPr>
           <a:xfrm>
             <a:off x="822960" y="5468112"/>
-            <a:ext cx="10954512" cy="548640"/>
+            <a:ext cx="10652760" cy="548640"/>
           </a:xfrm>
           <a:prstGeom prst="rtTriangle">
             <a:avLst/>
@@ -7479,7 +7479,7 @@
         </p:nvSpPr>
         <p:spPr>
           <a:xfrm>
-            <a:off x="7589520" y="5486400"/>
+            <a:off x="7543800" y="5486400"/>
             <a:ext cx="3931920" cy="274320"/>
           </a:xfrm>
           <a:prstGeom prst="rect">
@@ -7519,7 +7519,7 @@
         <p:spPr>
           <a:xfrm>
             <a:off x="822960" y="6126480"/>
-            <a:ext cx="10954512" cy="0"/>
+            <a:ext cx="10652760" cy="0"/>
           </a:xfrm>
           <a:prstGeom prst="line">
             <a:avLst/>
@@ -7753,11 +7753,11 @@
         <p:spPr>
           <a:xfrm>
             <a:off x="822960" y="1965960"/>
-            <a:ext cx="4983480" cy="2377440"/>
+            <a:ext cx="4983480" cy="2514600"/>
           </a:xfrm>
           <a:prstGeom prst="roundRect">
             <a:avLst>
-              <a:gd name="adj" fmla="val 2308"/>
+              <a:gd name="adj" fmla="val 2182"/>
             </a:avLst>
           </a:prstGeom>
           <a:solidFill>
@@ -7793,7 +7793,7 @@
             <a:r>
               <a:rPr lang="en-US" sz="1500" b="1" dirty="0">
                 <a:solidFill>
-                  <a:srgbClr val="7C8D97"/>
+                  <a:srgbClr val="3D5766"/>
                 </a:solidFill>
                 <a:latin typeface="Calibri" pitchFamily="34" charset="0"/>
                 <a:ea typeface="Calibri" pitchFamily="34" charset="-122"/>
@@ -7814,16 +7814,16 @@
         <p:spPr>
           <a:xfrm>
             <a:off x="1188720" y="2670048"/>
-            <a:ext cx="4251960" cy="1371600"/>
-          </a:xfrm>
-          <a:prstGeom prst="rect">
-            <a:avLst/>
-          </a:prstGeom>
-          <a:noFill/>
-          <a:ln/>
-        </p:spPr>
-        <p:txBody>
-          <a:bodyPr wrap="square" lIns="0" tIns="0" rIns="0" bIns="0" rtlCol="0" anchor="ctr"/>
+            <a:ext cx="4251960" cy="1600200"/>
+          </a:xfrm>
+          <a:prstGeom prst="rect">
+            <a:avLst/>
+          </a:prstGeom>
+          <a:noFill/>
+          <a:ln/>
+        </p:spPr>
+        <p:txBody>
+          <a:bodyPr wrap="square" lIns="0" tIns="0" rIns="0" bIns="0" rtlCol="0" anchor="t"/>
           <a:lstStyle/>
           <a:p>
             <a:pPr marL="342900" indent="-342900">
@@ -7908,11 +7908,11 @@
         <p:spPr>
           <a:xfrm>
             <a:off x="6355080" y="1965960"/>
-            <a:ext cx="4983480" cy="2377440"/>
+            <a:ext cx="4983480" cy="2514600"/>
           </a:xfrm>
           <a:prstGeom prst="roundRect">
             <a:avLst>
-              <a:gd name="adj" fmla="val 2308"/>
+              <a:gd name="adj" fmla="val 2182"/>
             </a:avLst>
           </a:prstGeom>
           <a:solidFill>
@@ -7969,7 +7969,7 @@
         <p:spPr>
           <a:xfrm>
             <a:off x="6720840" y="2670048"/>
-            <a:ext cx="4251960" cy="1554480"/>
+            <a:ext cx="4251960" cy="1600200"/>
           </a:xfrm>
           <a:prstGeom prst="rect">
             <a:avLst/>
@@ -8398,7 +8398,7 @@
         </p:nvSpPr>
         <p:spPr>
           <a:xfrm>
-            <a:off x="3662758" y="3690691"/>
+            <a:off x="3747349" y="3506747"/>
             <a:ext cx="292608" cy="274320"/>
           </a:xfrm>
           <a:prstGeom prst="rect">
@@ -8461,7 +8461,7 @@
         </p:nvSpPr>
         <p:spPr>
           <a:xfrm>
-            <a:off x="5380658" y="3386765"/>
+            <a:off x="5296067" y="3570709"/>
             <a:ext cx="292608" cy="274320"/>
           </a:xfrm>
           <a:prstGeom prst="rect">
@@ -8524,7 +8524,7 @@
         </p:nvSpPr>
         <p:spPr>
           <a:xfrm>
-            <a:off x="7667273" y="4357151"/>
+            <a:off x="7471249" y="4306498"/>
             <a:ext cx="292608" cy="274320"/>
           </a:xfrm>
           <a:prstGeom prst="rect">
@@ -8587,7 +8587,7 @@
         </p:nvSpPr>
         <p:spPr>
           <a:xfrm>
-            <a:off x="7063711" y="2720305"/>
+            <a:off x="7259735" y="2770958"/>
             <a:ext cx="292608" cy="274320"/>
           </a:xfrm>
           <a:prstGeom prst="rect">
@@ -8650,7 +8650,7 @@
         </p:nvSpPr>
         <p:spPr>
           <a:xfrm>
-            <a:off x="7018020" y="5161788"/>
+            <a:off x="6835140" y="5248656"/>
             <a:ext cx="292608" cy="274320"/>
           </a:xfrm>
           <a:prstGeom prst="rect">
@@ -8713,7 +8713,7 @@
         </p:nvSpPr>
         <p:spPr>
           <a:xfrm>
-            <a:off x="4869180" y="4293108"/>
+            <a:off x="5052060" y="4206240"/>
             <a:ext cx="292608" cy="274320"/>
           </a:xfrm>
           <a:prstGeom prst="rect">
@@ -9209,7 +9209,7 @@
           <a:ln/>
         </p:spPr>
         <p:txBody>
-          <a:bodyPr wrap="square" lIns="0" tIns="0" rIns="0" bIns="0" rtlCol="0" anchor="ctr"/>
+          <a:bodyPr wrap="square" lIns="0" tIns="0" rIns="0" bIns="0" rtlCol="0" anchor="t"/>
           <a:lstStyle/>
           <a:p>
             <a:pPr indent="0" marL="0">
@@ -9219,9 +9219,9 @@
               <a:buNone/>
             </a:pPr>
             <a:r>
-              <a:rPr lang="en-US" sz="1050" dirty="0">
-                <a:solidFill>
-                  <a:srgbClr val="7C8D97"/>
+              <a:rPr lang="en-US" sz="1100" dirty="0">
+                <a:solidFill>
+                  <a:srgbClr val="3D5766"/>
                 </a:solidFill>
                 <a:latin typeface="Calibri" pitchFamily="34" charset="0"/>
                 <a:ea typeface="Calibri" pitchFamily="34" charset="-122"/>
@@ -9229,7 +9229,7 @@
               </a:rPr>
               <a:t>+   the two move in the same direction</a:t>
             </a:r>
-            <a:endParaRPr lang="en-US" sz="1050" dirty="0"/>
+            <a:endParaRPr lang="en-US" sz="1100" dirty="0"/>
           </a:p>
           <a:p>
             <a:pPr indent="0" marL="0">
@@ -9239,9 +9239,9 @@
               <a:buNone/>
             </a:pPr>
             <a:r>
-              <a:rPr lang="en-US" sz="1050" dirty="0">
-                <a:solidFill>
-                  <a:srgbClr val="7C8D97"/>
+              <a:rPr lang="en-US" sz="1100" dirty="0">
+                <a:solidFill>
+                  <a:srgbClr val="3D5766"/>
                 </a:solidFill>
                 <a:latin typeface="Calibri" pitchFamily="34" charset="0"/>
                 <a:ea typeface="Calibri" pitchFamily="34" charset="-122"/>
@@ -9249,7 +9249,7 @@
               </a:rPr>
               <a:t>R   a loop that feeds itself</a:t>
             </a:r>
-            <a:endParaRPr lang="en-US" sz="1050" dirty="0"/>
+            <a:endParaRPr lang="en-US" sz="1100" dirty="0"/>
           </a:p>
         </p:txBody>
       </p:sp>
@@ -9310,7 +9310,7 @@
           <a:ln/>
         </p:spPr>
         <p:txBody>
-          <a:bodyPr wrap="square" lIns="0" tIns="0" rIns="0" bIns="0" rtlCol="0" anchor="ctr"/>
+          <a:bodyPr wrap="square" lIns="0" tIns="0" rIns="0" bIns="0" rtlCol="0" anchor="t"/>
           <a:lstStyle/>
           <a:p>
             <a:pPr indent="0" marL="0">
@@ -9391,7 +9391,7 @@
           <a:ln/>
         </p:spPr>
         <p:txBody>
-          <a:bodyPr wrap="square" lIns="0" tIns="0" rIns="0" bIns="0" rtlCol="0" anchor="ctr"/>
+          <a:bodyPr wrap="square" lIns="0" tIns="0" rIns="0" bIns="0" rtlCol="0" anchor="t"/>
           <a:lstStyle/>
           <a:p>
             <a:pPr indent="0" marL="0">
@@ -9472,7 +9472,7 @@
           <a:ln/>
         </p:spPr>
         <p:txBody>
-          <a:bodyPr wrap="square" lIns="0" tIns="0" rIns="0" bIns="0" rtlCol="0" anchor="ctr"/>
+          <a:bodyPr wrap="square" lIns="0" tIns="0" rIns="0" bIns="0" rtlCol="0" anchor="t"/>
           <a:lstStyle/>
           <a:p>
             <a:pPr indent="0" marL="0">

</xml_diff>